<commit_message>
updated presentation with link to dbt docs in github pages
</commit_message>
<xml_diff>
--- a/presentation/exercise_and_sustainability_presentation.pptx
+++ b/presentation/exercise_and_sustainability_presentation.pptx
@@ -14724,6 +14724,56 @@
           </a:prstGeom>
         </p:spPr>
       </p:pic>
+      <p:sp>
+        <p:nvSpPr>
+          <p:cNvPr id="43" name="TextBox 42">
+            <a:extLst>
+              <a:ext uri="{FF2B5EF4-FFF2-40B4-BE49-F238E27FC236}">
+                <a16:creationId xmlns:a16="http://schemas.microsoft.com/office/drawing/2014/main" id="{F479B744-55E1-A67D-A502-A76D1CFBBE18}"/>
+              </a:ext>
+            </a:extLst>
+          </p:cNvPr>
+          <p:cNvSpPr txBox="1"/>
+          <p:nvPr/>
+        </p:nvSpPr>
+        <p:spPr>
+          <a:xfrm>
+            <a:off x="0" y="6590173"/>
+            <a:ext cx="8517636" cy="246221"/>
+          </a:xfrm>
+          <a:prstGeom prst="rect">
+            <a:avLst/>
+          </a:prstGeom>
+          <a:noFill/>
+        </p:spPr>
+        <p:txBody>
+          <a:bodyPr wrap="square">
+            <a:spAutoFit/>
+          </a:bodyPr>
+          <a:lstStyle/>
+          <a:p>
+            <a:r>
+              <a:rPr lang="da-DK" sz="1000" dirty="0"/>
+              <a:t>Link to </a:t>
+            </a:r>
+            <a:r>
+              <a:rPr lang="da-DK" sz="1000" dirty="0" err="1"/>
+              <a:t>dbt</a:t>
+            </a:r>
+            <a:r>
+              <a:rPr lang="da-DK" sz="1000" dirty="0"/>
+              <a:t> docs: </a:t>
+            </a:r>
+            <a:r>
+              <a:rPr lang="da-DK" sz="1000" dirty="0">
+                <a:hlinkClick r:id="rId3"/>
+              </a:rPr>
+              <a:t>https://kaspergroenbek98.github.io/exercise_and_sustainability_case/</a:t>
+            </a:r>
+            <a:endParaRPr lang="da-DK" sz="1000" dirty="0"/>
+          </a:p>
+        </p:txBody>
+      </p:sp>
     </p:spTree>
   </p:cSld>
   <p:clrMapOvr>
@@ -17439,6 +17489,56 @@
               </a:rPr>
               <a:t>11 / 13</a:t>
             </a:r>
+          </a:p>
+        </p:txBody>
+      </p:sp>
+      <p:sp>
+        <p:nvSpPr>
+          <p:cNvPr id="35" name="TextBox 34">
+            <a:extLst>
+              <a:ext uri="{FF2B5EF4-FFF2-40B4-BE49-F238E27FC236}">
+                <a16:creationId xmlns:a16="http://schemas.microsoft.com/office/drawing/2014/main" id="{650E8790-4F5F-F03F-17A6-B0F5CC610114}"/>
+              </a:ext>
+            </a:extLst>
+          </p:cNvPr>
+          <p:cNvSpPr txBox="1"/>
+          <p:nvPr/>
+        </p:nvSpPr>
+        <p:spPr>
+          <a:xfrm>
+            <a:off x="0" y="6608461"/>
+            <a:ext cx="8517636" cy="246221"/>
+          </a:xfrm>
+          <a:prstGeom prst="rect">
+            <a:avLst/>
+          </a:prstGeom>
+          <a:noFill/>
+        </p:spPr>
+        <p:txBody>
+          <a:bodyPr wrap="square">
+            <a:spAutoFit/>
+          </a:bodyPr>
+          <a:lstStyle/>
+          <a:p>
+            <a:r>
+              <a:rPr lang="da-DK" sz="1000" dirty="0"/>
+              <a:t>Link to </a:t>
+            </a:r>
+            <a:r>
+              <a:rPr lang="da-DK" sz="1000" dirty="0" err="1"/>
+              <a:t>dbt</a:t>
+            </a:r>
+            <a:r>
+              <a:rPr lang="da-DK" sz="1000" dirty="0"/>
+              <a:t> docs: </a:t>
+            </a:r>
+            <a:r>
+              <a:rPr lang="da-DK" sz="1000" dirty="0">
+                <a:hlinkClick r:id="rId2"/>
+              </a:rPr>
+              <a:t>https://kaspergroenbek98.github.io/exercise_and_sustainability_case/</a:t>
+            </a:r>
+            <a:endParaRPr lang="da-DK" sz="1000" dirty="0"/>
           </a:p>
         </p:txBody>
       </p:sp>

</xml_diff>